<commit_message>
docs: troca nome da empresa para CleanTabaco (capa + rodape)
Atualiza a marca da empresa na capa, no rodape de todos os slides e nos
metadados para CleanTabaco. Os nomes de PRODUTOS (El Poncio Gudang...)
sao mantidos, pois sao marcas de produto e nao a empresa.

https://claude.ai/code/session_01UDDRg1dihv3LjYtZpr3mrb
</commit_message>
<xml_diff>
--- a/docs/apresentacoes/maio-2026/Apresentacao_Maio_2026.pptx
+++ b/docs/apresentacoes/maio-2026/Apresentacao_Maio_2026.pptx
@@ -4687,16 +4687,16 @@
                 </a:solidFill>
                 <a:latin typeface="Segoe UI Semibold"/>
               </a:rPr>
-              <a:t>EL PÔNCIO</a:t>
+              <a:t>CLEAN</a:t>
             </a:r>
             <a:r>
-              <a:rPr sz="1300" b="0" spc="200">
+              <a:rPr sz="1600" b="1" spc="400">
                 <a:solidFill>
                   <a:srgbClr val="9FC9CD"/>
                 </a:solidFill>
-                <a:latin typeface="Segoe UI"/>
+                <a:latin typeface="Segoe UI Semibold"/>
               </a:rPr>
-              <a:t>   ·   FAMÍLIA PÔNCIO</a:t>
+              <a:t>TABACO</a:t>
             </a:r>
           </a:p>
         </p:txBody>
@@ -8110,16 +8110,7 @@
                 </a:solidFill>
                 <a:latin typeface="Segoe UI Semibold"/>
               </a:rPr>
-              <a:t>EL PÔNCIO</a:t>
-            </a:r>
-            <a:r>
-              <a:rPr sz="900" b="0" spc="50">
-                <a:solidFill>
-                  <a:srgbClr val="7C8B92"/>
-                </a:solidFill>
-                <a:latin typeface="Segoe UI"/>
-              </a:rPr>
-              <a:t>   ·   Família Pôncio</a:t>
+              <a:t>CLEANTABACO</a:t>
             </a:r>
           </a:p>
         </p:txBody>
@@ -11304,16 +11295,7 @@
                 </a:solidFill>
                 <a:latin typeface="Segoe UI Semibold"/>
               </a:rPr>
-              <a:t>EL PÔNCIO</a:t>
-            </a:r>
-            <a:r>
-              <a:rPr sz="900" b="0" spc="50">
-                <a:solidFill>
-                  <a:srgbClr val="7C8B92"/>
-                </a:solidFill>
-                <a:latin typeface="Segoe UI"/>
-              </a:rPr>
-              <a:t>   ·   Família Pôncio</a:t>
+              <a:t>CLEANTABACO</a:t>
             </a:r>
           </a:p>
         </p:txBody>
@@ -12166,16 +12148,7 @@
                 </a:solidFill>
                 <a:latin typeface="Segoe UI Semibold"/>
               </a:rPr>
-              <a:t>EL PÔNCIO</a:t>
-            </a:r>
-            <a:r>
-              <a:rPr sz="900" b="0" spc="50">
-                <a:solidFill>
-                  <a:srgbClr val="7C8B92"/>
-                </a:solidFill>
-                <a:latin typeface="Segoe UI"/>
-              </a:rPr>
-              <a:t>   ·   Família Pôncio</a:t>
+              <a:t>CLEANTABACO</a:t>
             </a:r>
           </a:p>
         </p:txBody>
@@ -13294,16 +13267,7 @@
                 </a:solidFill>
                 <a:latin typeface="Segoe UI Semibold"/>
               </a:rPr>
-              <a:t>EL PÔNCIO</a:t>
-            </a:r>
-            <a:r>
-              <a:rPr sz="900" b="0" spc="50">
-                <a:solidFill>
-                  <a:srgbClr val="7C8B92"/>
-                </a:solidFill>
-                <a:latin typeface="Segoe UI"/>
-              </a:rPr>
-              <a:t>   ·   Família Pôncio</a:t>
+              <a:t>CLEANTABACO</a:t>
             </a:r>
           </a:p>
         </p:txBody>
@@ -14156,16 +14120,7 @@
                 </a:solidFill>
                 <a:latin typeface="Segoe UI Semibold"/>
               </a:rPr>
-              <a:t>EL PÔNCIO</a:t>
-            </a:r>
-            <a:r>
-              <a:rPr sz="900" b="0" spc="50">
-                <a:solidFill>
-                  <a:srgbClr val="7C8B92"/>
-                </a:solidFill>
-                <a:latin typeface="Segoe UI"/>
-              </a:rPr>
-              <a:t>   ·   Família Pôncio</a:t>
+              <a:t>CLEANTABACO</a:t>
             </a:r>
           </a:p>
         </p:txBody>
@@ -15171,16 +15126,7 @@
                 </a:solidFill>
                 <a:latin typeface="Segoe UI Semibold"/>
               </a:rPr>
-              <a:t>EL PÔNCIO</a:t>
-            </a:r>
-            <a:r>
-              <a:rPr sz="900" b="0" spc="50">
-                <a:solidFill>
-                  <a:srgbClr val="7C8B92"/>
-                </a:solidFill>
-                <a:latin typeface="Segoe UI"/>
-              </a:rPr>
-              <a:t>   ·   Família Pôncio</a:t>
+              <a:t>CLEANTABACO</a:t>
             </a:r>
           </a:p>
         </p:txBody>
@@ -16186,16 +16132,7 @@
                 </a:solidFill>
                 <a:latin typeface="Segoe UI Semibold"/>
               </a:rPr>
-              <a:t>EL PÔNCIO</a:t>
-            </a:r>
-            <a:r>
-              <a:rPr sz="900" b="0" spc="50">
-                <a:solidFill>
-                  <a:srgbClr val="7C8B92"/>
-                </a:solidFill>
-                <a:latin typeface="Segoe UI"/>
-              </a:rPr>
-              <a:t>   ·   Família Pôncio</a:t>
+              <a:t>CLEANTABACO</a:t>
             </a:r>
           </a:p>
         </p:txBody>
@@ -17201,16 +17138,7 @@
                 </a:solidFill>
                 <a:latin typeface="Segoe UI Semibold"/>
               </a:rPr>
-              <a:t>EL PÔNCIO</a:t>
-            </a:r>
-            <a:r>
-              <a:rPr sz="900" b="0" spc="50">
-                <a:solidFill>
-                  <a:srgbClr val="7C8B92"/>
-                </a:solidFill>
-                <a:latin typeface="Segoe UI"/>
-              </a:rPr>
-              <a:t>   ·   Família Pôncio</a:t>
+              <a:t>CLEANTABACO</a:t>
             </a:r>
           </a:p>
         </p:txBody>
@@ -19124,16 +19052,7 @@
                 </a:solidFill>
                 <a:latin typeface="Segoe UI Semibold"/>
               </a:rPr>
-              <a:t>EL PÔNCIO</a:t>
-            </a:r>
-            <a:r>
-              <a:rPr sz="900" b="0" spc="50">
-                <a:solidFill>
-                  <a:srgbClr val="7C8B92"/>
-                </a:solidFill>
-                <a:latin typeface="Segoe UI"/>
-              </a:rPr>
-              <a:t>   ·   Família Pôncio</a:t>
+              <a:t>CLEANTABACO</a:t>
             </a:r>
           </a:p>
         </p:txBody>
@@ -22318,16 +22237,7 @@
                 </a:solidFill>
                 <a:latin typeface="Segoe UI Semibold"/>
               </a:rPr>
-              <a:t>EL PÔNCIO</a:t>
-            </a:r>
-            <a:r>
-              <a:rPr sz="900" b="0" spc="50">
-                <a:solidFill>
-                  <a:srgbClr val="7C8B92"/>
-                </a:solidFill>
-                <a:latin typeface="Segoe UI"/>
-              </a:rPr>
-              <a:t>   ·   Família Pôncio</a:t>
+              <a:t>CLEANTABACO</a:t>
             </a:r>
           </a:p>
         </p:txBody>

</xml_diff>